<commit_message>
Recommendation carries Eileen's answer to the obvious objection
Asked whether the binary thumbs-up undermines the 12-point threshold. Her
answer: "a 12-point drop is still a 12-point drop." That separates a claim about
levels from a claim about change, which is the distinction the whole rule rests
on, and it is the natural consequence of the "direction, not measurement" line
she gave for Limitations.

Now in both the report and the deck. The authorship note marks this paragraph
and the Limitations opening as hers, to be left as written.

Co-Authored-By: Claude Opus 5 <noreply@anthropic.com>
</commit_message>
<xml_diff>
--- a/deliverables/launch-sentiment-deck.pptx
+++ b/deliverables/launch-sentiment-deck.pptx
@@ -3865,6 +3865,14 @@
             </a:pPr>
             <a:r>
               <a:t>When it trips, read the theme mix, not the reviews: the cause is named within hours</a:t>
+            </a:r>
+          </a:p>
+          <a:p>
+            <a:pPr>
+              <a:defRPr sz="1800"/>
+            </a:pPr>
+            <a:r>
+              <a:t>The thumbs-up is blunt, but that is about levels — a 12-point drop is still a 12-point drop</a:t>
             </a:r>
           </a:p>
           <a:p>

</xml_diff>

<commit_message>
Report, deck and case study carry Eileen's verdict on the null
"A good outcome, better than forcing a fake finding" — her words, answering the
question an interviewer will ask about a null result. Now opens a short "On the
result being a null" section in the report, leads the null slide in the deck,
and sits in the case study's interpretation.

Three passages in the drafted sections are now hers and marked not to be
overwritten: the Limitations opening, the threshold defence, and this.

Co-Authored-By: Claude Opus 5 <noreply@anthropic.com>
</commit_message>
<xml_diff>
--- a/deliverables/launch-sentiment-deck.pptx
+++ b/deliverables/launch-sentiment-deck.pptx
@@ -3566,6 +3566,14 @@
         <p:txBody>
           <a:bodyPr/>
           <a:lstStyle/>
+          <a:p>
+            <a:pPr>
+              <a:defRPr sz="1800"/>
+            </a:pPr>
+            <a:r>
+              <a:t>A good outcome — better than forcing a fake finding</a:t>
+            </a:r>
+          </a:p>
           <a:p>
             <a:pPr>
               <a:defRPr sz="1800"/>

</xml_diff>